<commit_message>
Finish roadmap: stages 3b, 4, 5 and 6, plus updated guide
- 3b: stage 3 in langchaingo
- 4: MCP server over stdio (hand-written JSON-RPC)
- 5: evals (request and conversation cases) with jokes-eval runner
- 6: provider switching (Ollama, OpenAI, Claude) behind one interface
- Update README, CLAUDE.md, Makefile, and the PDF and PPTX guide

Co-Authored-By: Claude Sonnet 5.5 <noreply@anthropic.com>
</commit_message>
<xml_diff>
--- a/docs/agent-lab-guide.pptx
+++ b/docs/agent-lab-guide.pptx
@@ -18,6 +18,8 @@
     <p:sldId id="266" r:id="rId12"/>
     <p:sldId id="267" r:id="rId13"/>
     <p:sldId id="268" r:id="rId14"/>
+    <p:sldId id="271" r:id="rId22"/>
+    <p:sldId id="272" r:id="rId23"/>
     <p:sldId id="269" r:id="rId15"/>
     <p:sldId id="270" r:id="rId16"/>
   </p:sldIdLst>
@@ -815,10 +817,8 @@
           <a:lstStyle/>
           <a:p>
             <a:r>
-              <a:rPr lang="en-US" dirty="0"/>
-              <a:t>Planned. The mapping is what to look for when comparing, not existing code.</a:t>
-            </a:r>
-            <a:endParaRPr lang="en-US" dirty="0"/>
+              <a:t>Stage 3b findings. The native langchaingo Ollama client ignores tool definitions, so we use its OpenAI client against Ollama /v1, which cannot set num_ctx or keep_alive. Tools take a single string. The executor aborts on tool errors. Memory is flattened text.</a:t>
+            </a:r>
           </a:p>
         </p:txBody>
       </p:sp>
@@ -903,10 +903,8 @@
           <a:lstStyle/>
           <a:p>
             <a:r>
-              <a:rPr lang="en-US" dirty="0"/>
-              <a:t>Both are planned.</a:t>
-            </a:r>
-            <a:endParaRPr lang="en-US" dirty="0"/>
+              <a:t>The MCP server exposes get_joke and search_dad_jokes. Claude Code can connect to it. Stage 6 reuses the same tool code in-process.</a:t>
+            </a:r>
           </a:p>
         </p:txBody>
       </p:sp>
@@ -1122,6 +1120,146 @@
 </p:notes>
 </file>
 
+<file path=ppt/notesSlides/notesSlide16.xml><?xml version="1.0" encoding="utf-8"?>
+<p:notes xmlns:a="http://schemas.openxmlformats.org/drawingml/2006/main" xmlns:p="http://schemas.openxmlformats.org/presentationml/2006/main" xmlns:r="http://schemas.openxmlformats.org/officeDocument/2006/relationships">
+  <p:cSld>
+    <p:spTree>
+      <p:nvGrpSpPr>
+        <p:cNvPr id="1" name=""/>
+        <p:cNvGrpSpPr/>
+        <p:nvPr/>
+      </p:nvGrpSpPr>
+      <p:grpSpPr>
+        <a:xfrm>
+          <a:off x="0" y="0"/>
+          <a:ext cx="0" cy="0"/>
+          <a:chOff x="0" y="0"/>
+          <a:chExt cx="0" cy="0"/>
+        </a:xfrm>
+      </p:grpSpPr>
+      <p:sp>
+        <p:nvSpPr>
+          <p:cNvPr id="2" name="Slide Image Placeholder 1"/>
+          <p:cNvSpPr>
+            <a:spLocks noGrp="1"/>
+          </p:cNvSpPr>
+          <p:nvPr>
+            <p:ph type="sldImg" idx="2"/>
+          </p:nvPr>
+        </p:nvSpPr>
+        <p:spPr/>
+      </p:sp>
+      <p:sp>
+        <p:nvSpPr>
+          <p:cNvPr id="3" name="Notes Placeholder 2"/>
+          <p:cNvSpPr>
+            <a:spLocks noGrp="1"/>
+          </p:cNvSpPr>
+          <p:nvPr>
+            <p:ph type="body" idx="3" sz="quarter"/>
+          </p:nvPr>
+        </p:nvSpPr>
+        <p:spPr/>
+        <p:txBody>
+          <a:bodyPr/>
+          <a:lstStyle/>
+          <a:p>
+            <a:r>
+              <a:t>Scores are single runs on the local model on 2026-10-06. The stage 0 score is exact. The stage 6 failure was the known unasked-explanation weakness.</a:t>
+            </a:r>
+          </a:p>
+        </p:txBody>
+      </p:sp>
+      <p:sp>
+        <p:nvSpPr>
+          <p:cNvPr id="4" name="Slide Number Placeholder 3"/>
+          <p:cNvSpPr>
+            <a:spLocks noGrp="1"/>
+          </p:cNvSpPr>
+          <p:nvPr>
+            <p:ph type="sldNum" idx="5" sz="quarter"/>
+          </p:nvPr>
+        </p:nvSpPr>
+        <p:spPr/>
+      </p:sp>
+    </p:spTree>
+  </p:cSld>
+  <p:clrMapOvr>
+    <a:masterClrMapping/>
+  </p:clrMapOvr>
+</p:notes>
+</file>
+
+<file path=ppt/notesSlides/notesSlide17.xml><?xml version="1.0" encoding="utf-8"?>
+<p:notes xmlns:a="http://schemas.openxmlformats.org/drawingml/2006/main" xmlns:p="http://schemas.openxmlformats.org/presentationml/2006/main" xmlns:r="http://schemas.openxmlformats.org/officeDocument/2006/relationships">
+  <p:cSld>
+    <p:spTree>
+      <p:nvGrpSpPr>
+        <p:cNvPr id="1" name=""/>
+        <p:cNvGrpSpPr/>
+        <p:nvPr/>
+      </p:nvGrpSpPr>
+      <p:grpSpPr>
+        <a:xfrm>
+          <a:off x="0" y="0"/>
+          <a:ext cx="0" cy="0"/>
+          <a:chOff x="0" y="0"/>
+          <a:chExt cx="0" cy="0"/>
+        </a:xfrm>
+      </p:grpSpPr>
+      <p:sp>
+        <p:nvSpPr>
+          <p:cNvPr id="2" name="Slide Image Placeholder 1"/>
+          <p:cNvSpPr>
+            <a:spLocks noGrp="1"/>
+          </p:cNvSpPr>
+          <p:nvPr>
+            <p:ph type="sldImg" idx="2"/>
+          </p:nvPr>
+        </p:nvSpPr>
+        <p:spPr/>
+      </p:sp>
+      <p:sp>
+        <p:nvSpPr>
+          <p:cNvPr id="3" name="Notes Placeholder 2"/>
+          <p:cNvSpPr>
+            <a:spLocks noGrp="1"/>
+          </p:cNvSpPr>
+          <p:nvPr>
+            <p:ph type="body" idx="3" sz="quarter"/>
+          </p:nvPr>
+        </p:nvSpPr>
+        <p:spPr/>
+        <p:txBody>
+          <a:bodyPr/>
+          <a:lstStyle/>
+          <a:p>
+            <a:r>
+              <a:t>Adapters hide the wire differences: system prompt placement, argument encoding, tool result placement and call IDs. Run the same eval per provider to compare.</a:t>
+            </a:r>
+          </a:p>
+        </p:txBody>
+      </p:sp>
+      <p:sp>
+        <p:nvSpPr>
+          <p:cNvPr id="4" name="Slide Number Placeholder 3"/>
+          <p:cNvSpPr>
+            <a:spLocks noGrp="1"/>
+          </p:cNvSpPr>
+          <p:nvPr>
+            <p:ph type="sldNum" idx="5" sz="quarter"/>
+          </p:nvPr>
+        </p:nvSpPr>
+        <p:spPr/>
+      </p:sp>
+    </p:spTree>
+  </p:cSld>
+  <p:clrMapOvr>
+    <a:masterClrMapping/>
+  </p:clrMapOvr>
+</p:notes>
+</file>
+
 <file path=ppt/notesSlides/notesSlide2.xml><?xml version="1.0" encoding="utf-8"?>
 <p:notes xmlns:a="http://schemas.openxmlformats.org/drawingml/2006/main" xmlns:r="http://schemas.openxmlformats.org/officeDocument/2006/relationships" xmlns:p="http://schemas.openxmlformats.org/presentationml/2006/main">
   <p:cSld>
@@ -1167,10 +1305,8 @@
           <a:lstStyle/>
           <a:p>
             <a:r>
-              <a:rPr lang="en-US" dirty="0"/>
-              <a:t>Solid stages are built. Dashed ones are on the roadmap.</a:t>
-            </a:r>
-            <a:endParaRPr lang="en-US" dirty="0"/>
+              <a:t>All eight stages are built and tested offline. Stage 6 OpenAI and Claude adapters have not run against the live APIs.</a:t>
+            </a:r>
           </a:p>
         </p:txBody>
       </p:sp>
@@ -2459,7 +2595,7 @@
                   <a:srgbClr val="CADCFC"/>
                 </a:solidFill>
               </a:rPr>
-              <a:t>One idea at a time, from keyword matching to tool-calling agents, in a project that fetches jokes.</a:t>
+              <a:t>One idea at a time, from keyword matching to tool-calling agents, MCP, evals and provider switching, in a project that fetches jokes.</a:t>
             </a:r>
             <a:endParaRPr lang="en-US" sz="2000" dirty="0"/>
           </a:p>
@@ -2495,7 +2631,7 @@
                   <a:srgbClr val="4CC9C0"/>
                 </a:solidFill>
               </a:rPr>
-              <a:t>agent-lab  ·  Go  ·  Ollama  ·  stages 0 to 3 built, 3b to 5 planned</a:t>
+              <a:t>agent-lab  ·  Go  ·  Ollama  ·  all stages 0 to 6 built</a:t>
             </a:r>
             <a:endParaRPr lang="en-US" sz="1400" dirty="0"/>
           </a:p>
@@ -3939,7 +4075,7 @@
                   <a:srgbClr val="0B3B3C"/>
                 </a:solidFill>
               </a:rPr>
-              <a:t>Next: stage 3b in langchaingo</a:t>
+              <a:t>Stage 3b: the same agent in langchaingo</a:t>
             </a:r>
             <a:endParaRPr lang="en-US" sz="3000" dirty="0"/>
           </a:p>
@@ -3961,7 +4097,7 @@
         </p:nvGraphicFramePr>
         <p:xfrm>
           <a:off x="457200" y="1280160"/>
-          <a:ext cx="8229600" cy="914400"/>
+          <a:ext cx="8229600" cy="1981200"/>
         </p:xfrm>
         <a:graphic>
           <a:graphicData uri="http://schemas.openxmlformats.org/drawingml/2006/table">
@@ -3972,7 +4108,7 @@
                 <a:gridCol w="2377440"/>
                 <a:gridCol w="3291840"/>
               </a:tblGrid>
-              <a:tr h="457200">
+              <a:tr h="330200">
                 <a:tc>
                   <a:txBody>
                     <a:bodyPr/>
@@ -3982,7 +4118,7 @@
                         <a:buNone/>
                       </a:pPr>
                       <a:r>
-                        <a:rPr lang="en-US" sz="1200" b="1" dirty="0">
+                        <a:rPr lang="en-US" sz="1000" b="1" dirty="0">
                           <a:solidFill>
                             <a:srgbClr val="FFFFFF"/>
                           </a:solidFill>
@@ -4043,7 +4179,7 @@
                         <a:buNone/>
                       </a:pPr>
                       <a:r>
-                        <a:rPr lang="en-US" sz="1200" b="1" dirty="0">
+                        <a:rPr lang="en-US" sz="1000" b="1" dirty="0">
                           <a:solidFill>
                             <a:srgbClr val="FFFFFF"/>
                           </a:solidFill>
@@ -4104,12 +4240,12 @@
                         <a:buNone/>
                       </a:pPr>
                       <a:r>
-                        <a:rPr lang="en-US" sz="1200" b="1" dirty="0">
+                        <a:rPr lang="en-US" sz="1000" b="1" dirty="0">
                           <a:solidFill>
                             <a:srgbClr val="FFFFFF"/>
                           </a:solidFill>
                         </a:rPr>
-                        <a:t>What to look for</a:t>
+                        <a:t>What we found</a:t>
                       </a:r>
                       <a:endParaRPr lang="en-US" sz="1200" dirty="0"/>
                     </a:p>
@@ -4157,7 +4293,7 @@
                   </a:tcPr>
                 </a:tc>
               </a:tr>
-              <a:tr h="457200">
+              <a:tr h="330200">
                 <a:tc>
                   <a:txBody>
                     <a:bodyPr/>
@@ -4167,7 +4303,7 @@
                         <a:buNone/>
                       </a:pPr>
                       <a:r>
-                        <a:rPr lang="en-US" sz="1400" dirty="0">
+                        <a:rPr lang="en-US" sz="1100" dirty="0">
                           <a:solidFill>
                             <a:srgbClr val="14212B"/>
                           </a:solidFill>
@@ -4225,12 +4361,12 @@
                         <a:buNone/>
                       </a:pPr>
                       <a:r>
-                        <a:rPr lang="en-US" sz="1400" dirty="0">
+                        <a:rPr lang="en-US" sz="1100" dirty="0">
                           <a:solidFill>
                             <a:srgbClr val="14212B"/>
                           </a:solidFill>
                         </a:rPr>
-                        <a:t>LLM provider object</a:t>
+                        <a:t>openai client on /v1</a:t>
                       </a:r>
                       <a:endParaRPr lang="en-US" sz="1400" dirty="0"/>
                     </a:p>
@@ -4283,12 +4419,12 @@
                         <a:buNone/>
                       </a:pPr>
                       <a:r>
-                        <a:rPr lang="en-US" sz="1400" dirty="0">
+                        <a:rPr lang="en-US" sz="1100" dirty="0">
                           <a:solidFill>
                             <a:srgbClr val="14212B"/>
                           </a:solidFill>
                         </a:rPr>
-                        <a:t>Are num_ctx and keep_alive reachable?</a:t>
+                        <a:t>Native client drops tools; /v1 has no num_ctx</a:t>
                       </a:r>
                       <a:endParaRPr lang="en-US" sz="1400" dirty="0"/>
                     </a:p>
@@ -4333,7 +4469,7 @@
                   </a:tcPr>
                 </a:tc>
               </a:tr>
-              <a:tr h="457200">
+              <a:tr h="330200">
                 <a:tc>
                   <a:txBody>
                     <a:bodyPr/>
@@ -4343,7 +4479,7 @@
                         <a:buNone/>
                       </a:pPr>
                       <a:r>
-                        <a:rPr lang="en-US" sz="1400" dirty="0">
+                        <a:rPr lang="en-US" sz="1100" dirty="0">
                           <a:solidFill>
                             <a:srgbClr val="14212B"/>
                           </a:solidFill>
@@ -4401,12 +4537,12 @@
                         <a:buNone/>
                       </a:pPr>
                       <a:r>
-                        <a:rPr lang="en-US" sz="1400" dirty="0">
+                        <a:rPr lang="en-US" sz="1100" dirty="0">
                           <a:solidFill>
                             <a:srgbClr val="14212B"/>
                           </a:solidFill>
                         </a:rPr>
-                        <a:t>Tool interface</a:t>
+                        <a:t>tools.Tool, one string</a:t>
                       </a:r>
                       <a:endParaRPr lang="en-US" sz="1400" dirty="0"/>
                     </a:p>
@@ -4459,12 +4595,12 @@
                         <a:buNone/>
                       </a:pPr>
                       <a:r>
-                        <a:rPr lang="en-US" sz="1400" dirty="0">
+                        <a:rPr lang="en-US" sz="1100" dirty="0">
                           <a:solidFill>
                             <a:srgbClr val="14212B"/>
                           </a:solidFill>
                         </a:rPr>
-                        <a:t>Can jokeapi.Schema() be reused?</a:t>
+                        <a:t>Typed schema becomes prose; JSON inside a string</a:t>
                       </a:r>
                       <a:endParaRPr lang="en-US" sz="1400" dirty="0"/>
                     </a:p>
@@ -4509,7 +4645,7 @@
                   </a:tcPr>
                 </a:tc>
               </a:tr>
-              <a:tr h="457200">
+              <a:tr h="330200">
                 <a:tc>
                   <a:txBody>
                     <a:bodyPr/>
@@ -4519,7 +4655,7 @@
                         <a:buNone/>
                       </a:pPr>
                       <a:r>
-                        <a:rPr lang="en-US" sz="1400" dirty="0">
+                        <a:rPr lang="en-US" sz="1100" dirty="0">
                           <a:solidFill>
                             <a:srgbClr val="14212B"/>
                           </a:solidFill>
@@ -4577,12 +4713,12 @@
                         <a:buNone/>
                       </a:pPr>
                       <a:r>
-                        <a:rPr lang="en-US" sz="1400" dirty="0">
+                        <a:rPr lang="en-US" sz="1100" dirty="0">
                           <a:solidFill>
                             <a:srgbClr val="14212B"/>
                           </a:solidFill>
                         </a:rPr>
-                        <a:t>Agent executor</a:t>
+                        <a:t>agents.Executor</a:t>
                       </a:r>
                       <a:endParaRPr lang="en-US" sz="1400" dirty="0"/>
                     </a:p>
@@ -4635,12 +4771,12 @@
                         <a:buNone/>
                       </a:pPr>
                       <a:r>
-                        <a:rPr lang="en-US" sz="1400" dirty="0">
+                        <a:rPr lang="en-US" sz="1100" dirty="0">
                           <a:solidFill>
                             <a:srgbClr val="14212B"/>
                           </a:solidFill>
                         </a:rPr>
-                        <a:t>Where is the step cap?</a:t>
+                        <a:t>A tool Go error aborts the run; return text instead</a:t>
                       </a:r>
                       <a:endParaRPr lang="en-US" sz="1400" dirty="0"/>
                     </a:p>
@@ -4685,7 +4821,7 @@
                   </a:tcPr>
                 </a:tc>
               </a:tr>
-              <a:tr h="457200">
+              <a:tr h="330200">
                 <a:tc>
                   <a:txBody>
                     <a:bodyPr/>
@@ -4695,7 +4831,7 @@
                         <a:buNone/>
                       </a:pPr>
                       <a:r>
-                        <a:rPr lang="en-US" sz="1400" dirty="0">
+                        <a:rPr lang="en-US" sz="1100" dirty="0">
                           <a:solidFill>
                             <a:srgbClr val="14212B"/>
                           </a:solidFill>
@@ -4753,12 +4889,12 @@
                         <a:buNone/>
                       </a:pPr>
                       <a:r>
-                        <a:rPr lang="en-US" sz="1400" dirty="0">
+                        <a:rPr lang="en-US" sz="1100" dirty="0">
                           <a:solidFill>
                             <a:srgbClr val="14212B"/>
                           </a:solidFill>
                         </a:rPr>
-                        <a:t>Memory component</a:t>
+                        <a:t>Window buffer</a:t>
                       </a:r>
                       <a:endParaRPr lang="en-US" sz="1400" dirty="0"/>
                     </a:p>
@@ -4811,12 +4947,12 @@
                         <a:buNone/>
                       </a:pPr>
                       <a:r>
-                        <a:rPr lang="en-US" sz="1400" dirty="0">
+                        <a:rPr lang="en-US" sz="1100" dirty="0">
                           <a:solidFill>
                             <a:srgbClr val="14212B"/>
                           </a:solidFill>
                         </a:rPr>
-                        <a:t>Is trimming turn-aware?</a:t>
+                        <a:t>Text only, flattened into the system prompt</a:t>
                       </a:r>
                       <a:endParaRPr lang="en-US" sz="1400" dirty="0"/>
                     </a:p>
@@ -4861,7 +4997,7 @@
                   </a:tcPr>
                 </a:tc>
               </a:tr>
-              <a:tr h="457200">
+              <a:tr h="330200">
                 <a:tc>
                   <a:txBody>
                     <a:bodyPr/>
@@ -4871,7 +5007,7 @@
                         <a:buNone/>
                       </a:pPr>
                       <a:r>
-                        <a:rPr lang="en-US" sz="1400" dirty="0">
+                        <a:rPr lang="en-US" sz="1100" dirty="0">
                           <a:solidFill>
                             <a:srgbClr val="14212B"/>
                           </a:solidFill>
@@ -4929,7 +5065,7 @@
                         <a:buNone/>
                       </a:pPr>
                       <a:r>
-                        <a:rPr lang="en-US" sz="1400" dirty="0">
+                        <a:rPr lang="en-US" sz="1100" dirty="0">
                           <a:solidFill>
                             <a:srgbClr val="14212B"/>
                           </a:solidFill>
@@ -4987,12 +5123,12 @@
                         <a:buNone/>
                       </a:pPr>
                       <a:r>
-                        <a:rPr lang="en-US" sz="1400" dirty="0">
+                        <a:rPr lang="en-US" sz="1100" dirty="0">
                           <a:solidFill>
                             <a:srgbClr val="14212B"/>
                           </a:solidFill>
                         </a:rPr>
-                        <a:t>Can you see every prompt?</a:t>
+                        <a:t>Works; token counts hide in GenerationInfo</a:t>
                       </a:r>
                       <a:endParaRPr lang="en-US" sz="1400" dirty="0"/>
                     </a:p>
@@ -5071,7 +5207,7 @@
                   <a:srgbClr val="5A6B78"/>
                 </a:solidFill>
               </a:rPr>
-              <a:t>Planned, not built yet. The goal is to see what a framework hides.</a:t>
+              <a:t>Built. A framework removes code, not decisions: stage 3 and 3b are both about 275 lines.</a:t>
             </a:r>
             <a:endParaRPr lang="en-US" sz="1400" dirty="0"/>
           </a:p>
@@ -5179,36 +5315,12 @@
                   <a:srgbClr val="0B3B3C"/>
                 </a:solidFill>
               </a:rPr>
-              <a:t>Stage 4: MCP, stage 5: evals</a:t>
+              <a:t>Stage 4: tools behind an MCP server</a:t>
             </a:r>
             <a:endParaRPr lang="en-US" sz="3000" dirty="0"/>
           </a:p>
         </p:txBody>
       </p:sp>
-      <p:pic>
-        <p:nvPicPr>
-          <p:cNvPr id="4" name="MCP diagram" descr="MCP diagram">    </p:cNvPr>
-          <p:cNvPicPr>
-            <a:picLocks noChangeAspect="1"/>
-          </p:cNvPicPr>
-          <p:nvPr/>
-        </p:nvPicPr>
-        <p:blipFill>
-          <a:blip r:embed="rId1"/>
-          <a:stretch>
-            <a:fillRect/>
-          </a:stretch>
-        </p:blipFill>
-        <p:spPr>
-          <a:xfrm>
-            <a:off x="365760" y="1674796"/>
-            <a:ext cx="4572000" cy="1588168"/>
-          </a:xfrm>
-          <a:prstGeom prst="rect">
-            <a:avLst/>
-          </a:prstGeom>
-        </p:spPr>
-      </p:pic>
       <p:sp>
         <p:nvSpPr>
           <p:cNvPr id="5" name="bullets"/>
@@ -5238,12 +5350,12 @@
               <a:buChar char="•"/>
             </a:pPr>
             <a:r>
-              <a:rPr lang="en-US" sz="1500" dirty="0">
+              <a:rPr lang="en-US" sz="1300" dirty="0">
                 <a:solidFill>
                   <a:schemeClr val="tx1"/>
                 </a:solidFill>
               </a:rPr>
-              <a:t>Stage 4: the joke tools become an MCP server that Claude Code and the agent both use</a:t>
+              <a:t>Hand-written JSON-RPC over stdio, about 160 lines, no SDK</a:t>
             </a:r>
             <a:endParaRPr lang="en-US" sz="1500" dirty="0"/>
           </a:p>
@@ -5256,12 +5368,12 @@
               <a:buChar char="•"/>
             </a:pPr>
             <a:r>
-              <a:rPr lang="en-US" sz="1500" dirty="0">
+              <a:rPr lang="en-US" sz="1300" dirty="0">
                 <a:solidFill>
                   <a:schemeClr val="tx1"/>
                 </a:solidFill>
               </a:rPr>
-              <a:t>Stage 5: a table of prompts mapped to expected requests, scored per stage</a:t>
+              <a:t>initialize, tools/list, tools/call; notifications get no reply</a:t>
             </a:r>
             <a:endParaRPr lang="en-US" sz="1500" dirty="0"/>
           </a:p>
@@ -5274,12 +5386,48 @@
               <a:buChar char="•"/>
             </a:pPr>
             <a:r>
-              <a:rPr lang="en-US" sz="1500" dirty="0">
+              <a:rPr lang="en-US" sz="1300" dirty="0">
                 <a:solidFill>
                   <a:schemeClr val="tx1"/>
                 </a:solidFill>
               </a:rPr>
-              <a:t>Known weaknesses become eval cases</a:t>
+              <a:t>stdout is the protocol, so -trace logs to stderr</a:t>
+            </a:r>
+            <a:endParaRPr lang="en-US" sz="1500" dirty="0"/>
+          </a:p>
+          <a:p>
+            <a:pPr marL="342900" indent="-342900">
+              <a:spcAft>
+                <a:spcPts val="800"/>
+              </a:spcAft>
+              <a:buSzPct val="100000"/>
+              <a:buChar char="•"/>
+            </a:pPr>
+            <a:r>
+              <a:rPr lang="en-US" sz="1300" dirty="0">
+                <a:solidFill>
+                  <a:schemeClr val="tx1"/>
+                </a:solidFill>
+              </a:rPr>
+              <a:t>A failing tool returns isError, not a protocol error</a:t>
+            </a:r>
+            <a:endParaRPr lang="en-US" sz="1500" dirty="0"/>
+          </a:p>
+          <a:p>
+            <a:pPr marL="342900" indent="-342900">
+              <a:spcAft>
+                <a:spcPts val="800"/>
+              </a:spcAft>
+              <a:buSzPct val="100000"/>
+              <a:buChar char="•"/>
+            </a:pPr>
+            <a:r>
+              <a:rPr lang="en-US" sz="1300" dirty="0">
+                <a:solidFill>
+                  <a:schemeClr val="tx1"/>
+                </a:solidFill>
+              </a:rPr>
+              <a:t>claude mcp add jokes -- go run ./cmd/jokes-mcp</a:t>
             </a:r>
             <a:endParaRPr lang="en-US" sz="1500" dirty="0"/>
           </a:p>
@@ -5293,7 +5441,7 @@
         </p:nvSpPr>
         <p:spPr>
           <a:xfrm>
-            <a:off x="457200" y="4023360"/>
+            <a:off x="457200" y="4000000"/>
             <a:ext cx="4389120" cy="365760"/>
           </a:xfrm>
           <a:prstGeom prst="rect">
@@ -5315,7 +5463,7 @@
                   <a:srgbClr val="5A6B78"/>
                 </a:solidFill>
               </a:rPr>
-              <a:t>Planned shape: one tool implementation, many clients.</a:t>
+              <a:t>The client owns the model and the loop; the server only runs tools.</a:t>
             </a:r>
             <a:endParaRPr lang="en-US" sz="1200" dirty="0"/>
           </a:p>
@@ -5366,6 +5514,30 @@
           </a:p>
         </p:txBody>
       </p:sp>
+      <p:pic>
+        <p:nvPicPr>
+          <p:cNvPr id="26" name="Picture 25" descr="d4.png"/>
+          <p:cNvPicPr>
+            <a:picLocks noChangeAspect="1"/>
+          </p:cNvPicPr>
+          <p:nvPr/>
+        </p:nvPicPr>
+        <p:blipFill>
+          <a:blip r:embed="rId4"/>
+          <a:stretch>
+            <a:fillRect/>
+          </a:stretch>
+        </p:blipFill>
+        <p:spPr>
+          <a:xfrm>
+            <a:off x="365760" y="1280160"/>
+            <a:ext cx="4480000" cy="2691204"/>
+          </a:xfrm>
+          <a:prstGeom prst="rect">
+            <a:avLst/>
+          </a:prstGeom>
+        </p:spPr>
+      </p:pic>
     </p:spTree>
   </p:cSld>
   <p:clrMapOvr>
@@ -5375,6 +5547,528 @@
 </file>
 
 <file path=ppt/slides/slide14.xml><?xml version="1.0" encoding="utf-8"?>
+<p:sld xmlns:a="http://schemas.openxmlformats.org/drawingml/2006/main" xmlns:p="http://schemas.openxmlformats.org/presentationml/2006/main" xmlns:r="http://schemas.openxmlformats.org/officeDocument/2006/relationships">
+  <p:cSld>
+    <p:spTree>
+      <p:nvGrpSpPr>
+        <p:cNvPr id="1" name=""/>
+        <p:cNvGrpSpPr/>
+        <p:nvPr/>
+      </p:nvGrpSpPr>
+      <p:grpSpPr/>
+      <p:sp>
+        <p:nvSpPr>
+          <p:cNvPr id="2" name="Text 0"/>
+          <p:cNvSpPr/>
+          <p:nvPr>
+            <p:ph idx="100" type="title" hasCustomPrompt="1"/>
+          </p:nvPr>
+        </p:nvSpPr>
+        <p:spPr>
+          <a:xfrm>
+            <a:off x="457200" y="274320"/>
+            <a:ext cx="8229600" cy="731520"/>
+          </a:xfrm>
+          <a:prstGeom prst="rect">
+            <a:avLst/>
+          </a:prstGeom>
+          <a:noFill/>
+          <a:ln/>
+        </p:spPr>
+        <p:txBody>
+          <a:bodyPr wrap="square" lIns="0" tIns="0" rIns="0" bIns="0" rtlCol="0" anchor="ctr"/>
+          <a:lstStyle/>
+          <a:p>
+            <a:pPr algn="l" indent="0" marL="0">
+              <a:buNone/>
+            </a:pPr>
+            <a:r>
+              <a:rPr lang="en-US" sz="3000" b="1" dirty="0">
+                <a:solidFill>
+                  <a:srgbClr val="0B3B3C"/>
+                </a:solidFill>
+              </a:rPr>
+              <a:t>Stage 5: evals</a:t>
+            </a:r>
+            <a:endParaRPr lang="en-US" sz="3000" dirty="0"/>
+          </a:p>
+        </p:txBody>
+      </p:sp>
+      <p:sp>
+        <p:nvSpPr>
+          <p:cNvPr id="5" name="bullets"/>
+          <p:cNvSpPr txBox="1"/>
+          <p:nvPr/>
+        </p:nvSpPr>
+        <p:spPr>
+          <a:xfrm>
+            <a:off x="457200" y="1280160"/>
+            <a:ext cx="8229600" cy="3017520"/>
+          </a:xfrm>
+          <a:prstGeom prst="rect">
+            <a:avLst/>
+          </a:prstGeom>
+          <a:noFill/>
+          <a:ln/>
+        </p:spPr>
+        <p:txBody>
+          <a:bodyPr wrap="square" lIns="0" tIns="0" rIns="0" bIns="0" rtlCol="0" anchor="t"/>
+          <a:lstStyle/>
+          <a:p>
+            <a:pPr marL="342900" indent="-342900">
+              <a:spcAft>
+                <a:spcPts val="800"/>
+              </a:spcAft>
+              <a:buSzPct val="100000"/>
+              <a:buChar char="•"/>
+            </a:pPr>
+            <a:r>
+              <a:rPr lang="en-US" sz="1400" dirty="0">
+                <a:solidFill>
+                  <a:schemeClr val="tx1"/>
+                </a:solidFill>
+              </a:rPr>
+              <a:t>13 request cases and 6 conversation cases, with plain Go checks</a:t>
+            </a:r>
+            <a:endParaRPr lang="en-US" sz="1500" dirty="0"/>
+          </a:p>
+          <a:p>
+            <a:pPr marL="342900" indent="-342900">
+              <a:spcAft>
+                <a:spcPts val="800"/>
+              </a:spcAft>
+              <a:buSzPct val="100000"/>
+              <a:buChar char="•"/>
+            </a:pPr>
+            <a:r>
+              <a:rPr lang="en-US" sz="1400" dirty="0">
+                <a:solidFill>
+                  <a:schemeClr val="tx1"/>
+                </a:solidFill>
+              </a:rPr>
+              <a:t>Checks read typed requests and tool calls, not reply prose</a:t>
+            </a:r>
+            <a:endParaRPr lang="en-US" sz="1500" dirty="0"/>
+          </a:p>
+          <a:p>
+            <a:pPr marL="342900" indent="-342900">
+              <a:spcAft>
+                <a:spcPts val="800"/>
+              </a:spcAft>
+              <a:buSzPct val="100000"/>
+              <a:buChar char="•"/>
+            </a:pPr>
+            <a:r>
+              <a:rPr lang="en-US" sz="1400" dirty="0">
+                <a:solidFill>
+                  <a:schemeClr val="tx1"/>
+                </a:solidFill>
+              </a:rPr>
+              <a:t>Stage 0: 7 of 13.  Stage 1 (qwen3.5:9b-mlx): 8 of 13.  Stage 6 agent: 5 of 6</a:t>
+            </a:r>
+            <a:endParaRPr lang="en-US" sz="1500" dirty="0"/>
+          </a:p>
+          <a:p>
+            <a:pPr marL="342900" indent="-342900">
+              <a:spcAft>
+                <a:spcPts val="800"/>
+              </a:spcAft>
+              <a:buSzPct val="100000"/>
+              <a:buChar char="•"/>
+            </a:pPr>
+            <a:r>
+              <a:rPr lang="en-US" sz="1400" dirty="0">
+                <a:solidFill>
+                  <a:schemeClr val="tx1"/>
+                </a:solidFill>
+              </a:rPr>
+              <a:t>Known weaknesses are cases on purpose: clean, no-unasked-explanations</a:t>
+            </a:r>
+            <a:endParaRPr lang="en-US" sz="1500" dirty="0"/>
+          </a:p>
+          <a:p>
+            <a:pPr marL="342900" indent="-342900">
+              <a:spcAft>
+                <a:spcPts val="800"/>
+              </a:spcAft>
+              <a:buSzPct val="100000"/>
+              <a:buChar char="•"/>
+            </a:pPr>
+            <a:r>
+              <a:rPr lang="en-US" sz="1400" dirty="0">
+                <a:solidFill>
+                  <a:schemeClr val="tx1"/>
+                </a:solidFill>
+              </a:rPr>
+              <a:t>One run each; use -n 3 for pass rates</a:t>
+            </a:r>
+            <a:endParaRPr lang="en-US" sz="1500" dirty="0"/>
+          </a:p>
+        </p:txBody>
+      </p:sp>
+      <p:sp>
+        <p:nvSpPr>
+          <p:cNvPr id="6" name="caption"/>
+          <p:cNvSpPr txBox="1"/>
+          <p:nvPr/>
+        </p:nvSpPr>
+        <p:spPr>
+          <a:xfrm>
+            <a:off x="457200" y="4297680"/>
+            <a:ext cx="4389120" cy="365760"/>
+          </a:xfrm>
+          <a:prstGeom prst="rect">
+            <a:avLst/>
+          </a:prstGeom>
+          <a:noFill/>
+          <a:ln/>
+        </p:spPr>
+        <p:txBody>
+          <a:bodyPr wrap="square" lIns="0" tIns="0" rIns="0" bIns="0" rtlCol="0" anchor="ctr"/>
+          <a:lstStyle/>
+          <a:p>
+            <a:pPr indent="0" marL="0">
+              <a:buNone/>
+            </a:pPr>
+            <a:r>
+              <a:rPr lang="en-US" sz="1200" dirty="0">
+                <a:solidFill>
+                  <a:srgbClr val="5A6B78"/>
+                </a:solidFill>
+              </a:rPr>
+              <a:t>make eval  ·  go run ./cmd/jokes-eval -stage 1 -n 3</a:t>
+            </a:r>
+            <a:endParaRPr lang="en-US" sz="1200" dirty="0"/>
+          </a:p>
+        </p:txBody>
+      </p:sp>
+      <p:sp>
+        <p:nvSpPr>
+          <p:cNvPr id="25" name="Slide Number Placeholder 0"/>
+          <p:cNvSpPr>
+            <a:spLocks noGrp="1"/>
+          </p:cNvSpPr>
+          <p:nvPr>
+            <p:ph type="sldNum" sz="quarter" idx="4294967295"/>
+          </p:nvPr>
+        </p:nvSpPr>
+        <p:spPr>
+          <a:xfrm>
+            <a:off x="8412480" y="4754880"/>
+            <a:ext cx="457200" cy="274320"/>
+          </a:xfrm>
+          <a:prstGeom prst="rect">
+            <a:avLst/>
+          </a:prstGeom>
+          <a:extLst>
+            <a:ext uri="{C572A759-6A51-4108-AA02-DFA0A04FC94B}">
+              <ma14:wrappingTextBoxFlag xmlns:ma14="http://schemas.microsoft.com/office/mac/drawingml/2011/main" val="0"/>
+            </a:ext>
+          </a:extLst>
+        </p:spPr>
+        <p:txBody>
+          <a:bodyPr/>
+          <a:lstStyle>
+            <a:lvl1pPr>
+              <a:defRPr sz="1000">
+                <a:solidFill>
+                  <a:srgbClr val="7A8A96"/>
+                </a:solidFill>
+              </a:defRPr>
+            </a:lvl1pPr>
+          </a:lstStyle>
+          <a:p>
+            <a:pPr algn="l"/>
+            <a:fld id="{F7021451-1387-4CA6-816F-3879F97B5CBC}" type="slidenum">
+              <a:rPr b="0" lang="en-US"/>
+              <a:t>13</a:t>
+            </a:fld>
+            <a:endParaRPr lang="en-US"/>
+          </a:p>
+        </p:txBody>
+      </p:sp>
+    </p:spTree>
+  </p:cSld>
+  <p:clrMapOvr>
+    <a:masterClrMapping/>
+  </p:clrMapOvr>
+</p:sld>
+</file>
+
+<file path=ppt/slides/slide15.xml><?xml version="1.0" encoding="utf-8"?>
+<p:sld xmlns:a="http://schemas.openxmlformats.org/drawingml/2006/main" xmlns:p="http://schemas.openxmlformats.org/presentationml/2006/main" xmlns:r="http://schemas.openxmlformats.org/officeDocument/2006/relationships">
+  <p:cSld>
+    <p:spTree>
+      <p:nvGrpSpPr>
+        <p:cNvPr id="1" name=""/>
+        <p:cNvGrpSpPr/>
+        <p:nvPr/>
+      </p:nvGrpSpPr>
+      <p:grpSpPr/>
+      <p:sp>
+        <p:nvSpPr>
+          <p:cNvPr id="2" name="Text 0"/>
+          <p:cNvSpPr/>
+          <p:nvPr>
+            <p:ph idx="100" type="title" hasCustomPrompt="1"/>
+          </p:nvPr>
+        </p:nvSpPr>
+        <p:spPr>
+          <a:xfrm>
+            <a:off x="457200" y="274320"/>
+            <a:ext cx="8229600" cy="731520"/>
+          </a:xfrm>
+          <a:prstGeom prst="rect">
+            <a:avLst/>
+          </a:prstGeom>
+          <a:noFill/>
+          <a:ln/>
+        </p:spPr>
+        <p:txBody>
+          <a:bodyPr wrap="square" lIns="0" tIns="0" rIns="0" bIns="0" rtlCol="0" anchor="ctr"/>
+          <a:lstStyle/>
+          <a:p>
+            <a:pPr algn="l" indent="0" marL="0">
+              <a:buNone/>
+            </a:pPr>
+            <a:r>
+              <a:rPr lang="en-US" sz="3000" b="1" dirty="0">
+                <a:solidFill>
+                  <a:srgbClr val="0B3B3C"/>
+                </a:solidFill>
+              </a:rPr>
+              <a:t>Stage 6: one loop, any provider</a:t>
+            </a:r>
+            <a:endParaRPr lang="en-US" sz="3000" dirty="0"/>
+          </a:p>
+        </p:txBody>
+      </p:sp>
+      <p:sp>
+        <p:nvSpPr>
+          <p:cNvPr id="5" name="bullets"/>
+          <p:cNvSpPr txBox="1"/>
+          <p:nvPr/>
+        </p:nvSpPr>
+        <p:spPr>
+          <a:xfrm>
+            <a:off x="5120640" y="1280160"/>
+            <a:ext cx="3657600" cy="3017520"/>
+          </a:xfrm>
+          <a:prstGeom prst="rect">
+            <a:avLst/>
+          </a:prstGeom>
+          <a:noFill/>
+          <a:ln/>
+        </p:spPr>
+        <p:txBody>
+          <a:bodyPr wrap="square" lIns="0" tIns="0" rIns="0" bIns="0" rtlCol="0" anchor="t"/>
+          <a:lstStyle/>
+          <a:p>
+            <a:pPr marL="342900" indent="-342900">
+              <a:spcAft>
+                <a:spcPts val="800"/>
+              </a:spcAft>
+              <a:buSzPct val="100000"/>
+              <a:buChar char="•"/>
+            </a:pPr>
+            <a:r>
+              <a:rPr lang="en-US" sz="1200" dirty="0">
+                <a:solidFill>
+                  <a:schemeClr val="tx1"/>
+                </a:solidFill>
+              </a:rPr>
+              <a:t>provider.Provider: system, messages, tools in; one message out</a:t>
+            </a:r>
+            <a:endParaRPr lang="en-US" sz="1500" dirty="0"/>
+          </a:p>
+          <a:p>
+            <a:pPr marL="342900" indent="-342900">
+              <a:spcAft>
+                <a:spcPts val="800"/>
+              </a:spcAft>
+              <a:buSzPct val="100000"/>
+              <a:buChar char="•"/>
+            </a:pPr>
+            <a:r>
+              <a:rPr lang="en-US" sz="1200" dirty="0">
+                <a:solidFill>
+                  <a:schemeClr val="tx1"/>
+                </a:solidFill>
+              </a:rPr>
+              <a:t>Ollama, OpenAI and Claude adapters in plain HTTP</a:t>
+            </a:r>
+            <a:endParaRPr lang="en-US" sz="1500" dirty="0"/>
+          </a:p>
+          <a:p>
+            <a:pPr marL="342900" indent="-342900">
+              <a:spcAft>
+                <a:spcPts val="800"/>
+              </a:spcAft>
+              <a:buSzPct val="100000"/>
+              <a:buChar char="•"/>
+            </a:pPr>
+            <a:r>
+              <a:rPr lang="en-US" sz="1200" dirty="0">
+                <a:solidFill>
+                  <a:schemeClr val="tx1"/>
+                </a:solidFill>
+              </a:rPr>
+              <a:t>OpenAI args are a JSON string; Claude wants tool results in a user message</a:t>
+            </a:r>
+            <a:endParaRPr lang="en-US" sz="1500" dirty="0"/>
+          </a:p>
+          <a:p>
+            <a:pPr marL="342900" indent="-342900">
+              <a:spcAft>
+                <a:spcPts val="800"/>
+              </a:spcAft>
+              <a:buSzPct val="100000"/>
+              <a:buChar char="•"/>
+            </a:pPr>
+            <a:r>
+              <a:rPr lang="en-US" sz="1200" dirty="0">
+                <a:solidFill>
+                  <a:schemeClr val="tx1"/>
+                </a:solidFill>
+              </a:rPr>
+              <a:t>Tools are stage 4's; the repeat check moved into the loop</a:t>
+            </a:r>
+            <a:endParaRPr lang="en-US" sz="1500" dirty="0"/>
+          </a:p>
+          <a:p>
+            <a:pPr marL="342900" indent="-342900">
+              <a:spcAft>
+                <a:spcPts val="800"/>
+              </a:spcAft>
+              <a:buSzPct val="100000"/>
+              <a:buChar char="•"/>
+            </a:pPr>
+            <a:r>
+              <a:rPr lang="en-US" sz="1200" dirty="0">
+                <a:solidFill>
+                  <a:schemeClr val="tx1"/>
+                </a:solidFill>
+              </a:rPr>
+              <a:t>OpenAI and Claude tested on fakes only, not yet live</a:t>
+            </a:r>
+            <a:endParaRPr lang="en-US" sz="1500" dirty="0"/>
+          </a:p>
+        </p:txBody>
+      </p:sp>
+      <p:sp>
+        <p:nvSpPr>
+          <p:cNvPr id="6" name="caption"/>
+          <p:cNvSpPr txBox="1"/>
+          <p:nvPr/>
+        </p:nvSpPr>
+        <p:spPr>
+          <a:xfrm>
+            <a:off x="457200" y="3000000"/>
+            <a:ext cx="4389120" cy="365760"/>
+          </a:xfrm>
+          <a:prstGeom prst="rect">
+            <a:avLst/>
+          </a:prstGeom>
+          <a:noFill/>
+          <a:ln/>
+        </p:spPr>
+        <p:txBody>
+          <a:bodyPr wrap="square" lIns="0" tIns="0" rIns="0" bIns="0" rtlCol="0" anchor="ctr"/>
+          <a:lstStyle/>
+          <a:p>
+            <a:pPr indent="0" marL="0">
+              <a:buNone/>
+            </a:pPr>
+            <a:r>
+              <a:rPr lang="en-US" sz="1200" dirty="0">
+                <a:solidFill>
+                  <a:srgbClr val="5A6B78"/>
+                </a:solidFill>
+              </a:rPr>
+              <a:t>-stage 6 -provider ollama | openai | claude</a:t>
+            </a:r>
+            <a:endParaRPr lang="en-US" sz="1200" dirty="0"/>
+          </a:p>
+        </p:txBody>
+      </p:sp>
+      <p:sp>
+        <p:nvSpPr>
+          <p:cNvPr id="25" name="Slide Number Placeholder 0"/>
+          <p:cNvSpPr>
+            <a:spLocks noGrp="1"/>
+          </p:cNvSpPr>
+          <p:nvPr>
+            <p:ph type="sldNum" sz="quarter" idx="4294967295"/>
+          </p:nvPr>
+        </p:nvSpPr>
+        <p:spPr>
+          <a:xfrm>
+            <a:off x="8412480" y="4754880"/>
+            <a:ext cx="457200" cy="274320"/>
+          </a:xfrm>
+          <a:prstGeom prst="rect">
+            <a:avLst/>
+          </a:prstGeom>
+          <a:extLst>
+            <a:ext uri="{C572A759-6A51-4108-AA02-DFA0A04FC94B}">
+              <ma14:wrappingTextBoxFlag xmlns:ma14="http://schemas.microsoft.com/office/mac/drawingml/2011/main" val="0"/>
+            </a:ext>
+          </a:extLst>
+        </p:spPr>
+        <p:txBody>
+          <a:bodyPr/>
+          <a:lstStyle>
+            <a:lvl1pPr>
+              <a:defRPr sz="1000">
+                <a:solidFill>
+                  <a:srgbClr val="7A8A96"/>
+                </a:solidFill>
+              </a:defRPr>
+            </a:lvl1pPr>
+          </a:lstStyle>
+          <a:p>
+            <a:pPr algn="l"/>
+            <a:fld id="{F7021451-1387-4CA6-816F-3879F97B5CBC}" type="slidenum">
+              <a:rPr b="0" lang="en-US"/>
+              <a:t>13</a:t>
+            </a:fld>
+            <a:endParaRPr lang="en-US"/>
+          </a:p>
+        </p:txBody>
+      </p:sp>
+      <p:pic>
+        <p:nvPicPr>
+          <p:cNvPr id="26" name="Picture 25" descr="d6.png"/>
+          <p:cNvPicPr>
+            <a:picLocks noChangeAspect="1"/>
+          </p:cNvPicPr>
+          <p:nvPr/>
+        </p:nvPicPr>
+        <p:blipFill>
+          <a:blip r:embed="rId2"/>
+          <a:stretch>
+            <a:fillRect/>
+          </a:stretch>
+        </p:blipFill>
+        <p:spPr>
+          <a:xfrm>
+            <a:off x="365760" y="1500000"/>
+            <a:ext cx="4480000" cy="1502243"/>
+          </a:xfrm>
+          <a:prstGeom prst="rect">
+            <a:avLst/>
+          </a:prstGeom>
+        </p:spPr>
+      </p:pic>
+    </p:spTree>
+  </p:cSld>
+  <p:clrMapOvr>
+    <a:masterClrMapping/>
+  </p:clrMapOvr>
+</p:sld>
+</file>
+
+<file path=ppt/slides/slide16.xml><?xml version="1.0" encoding="utf-8"?>
 <p:sld xmlns:a="http://schemas.openxmlformats.org/drawingml/2006/main" xmlns:r="http://schemas.openxmlformats.org/officeDocument/2006/relationships" xmlns:p="http://schemas.openxmlformats.org/presentationml/2006/main">
   <p:cSld name="Slide 14">
     <p:spTree>
@@ -6930,7 +7624,7 @@
 </p:sld>
 </file>
 
-<file path=ppt/slides/slide15.xml><?xml version="1.0" encoding="utf-8"?>
+<file path=ppt/slides/slide17.xml><?xml version="1.0" encoding="utf-8"?>
 <p:sld xmlns:a="http://schemas.openxmlformats.org/drawingml/2006/main" xmlns:r="http://schemas.openxmlformats.org/officeDocument/2006/relationships" xmlns:p="http://schemas.openxmlformats.org/presentationml/2006/main">
   <p:cSld name="Slide 15">
     <p:spTree>
@@ -7481,7 +8175,7 @@
                 <a:ea typeface="Courier New" pitchFamily="34" charset="-122"/>
                 <a:cs typeface="Courier New" pitchFamily="34" charset="-120"/>
               </a:rPr>
-              <a:t>make test   ·   go run ./cmd/jokes -stage 3 -trace</a:t>
+              <a:t>make test   ·   make eval   ·   go run ./cmd/jokes -stage 3 -trace</a:t>
             </a:r>
             <a:endParaRPr lang="en-US" sz="1400" dirty="0"/>
           </a:p>
@@ -7589,7 +8283,7 @@
                   <a:srgbClr val="0B3B3C"/>
                 </a:solidFill>
               </a:rPr>
-              <a:t>Six steps, one dial: who is in charge?</a:t>
+              <a:t>Eight stages, one dial: who is in charge?</a:t>
             </a:r>
             <a:endParaRPr lang="en-US" sz="3000" dirty="0"/>
           </a:p>
@@ -7604,7 +8298,7 @@
         <p:spPr>
           <a:xfrm>
             <a:off x="457200" y="1280160"/>
-            <a:ext cx="1097280" cy="1371600"/>
+            <a:ext cx="948690" cy="1371600"/>
           </a:xfrm>
           <a:prstGeom prst="roundRect">
             <a:avLst>
@@ -7618,7 +8312,6 @@
             <a:solidFill>
               <a:srgbClr val="7A8A96"/>
             </a:solidFill>
-            <a:prstDash val="solid"/>
           </a:ln>
         </p:spPr>
       </p:sp>
@@ -7631,7 +8324,7 @@
         <p:spPr>
           <a:xfrm>
             <a:off x="457200" y="1280160"/>
-            <a:ext cx="1097280" cy="1371600"/>
+            <a:ext cx="948690" cy="1371600"/>
           </a:xfrm>
           <a:prstGeom prst="rect">
             <a:avLst/>
@@ -7664,7 +8357,7 @@
               <a:buNone/>
             </a:pPr>
             <a:r>
-              <a:rPr lang="en-US" sz="1200" b="1" dirty="0">
+              <a:rPr lang="en-US" sz="1000" b="1" dirty="0">
                 <a:solidFill>
                   <a:srgbClr val="FFFFFF"/>
                 </a:solidFill>
@@ -7678,7 +8371,7 @@
               <a:buNone/>
             </a:pPr>
             <a:r>
-              <a:rPr lang="en-US" sz="1100" dirty="0">
+              <a:rPr lang="en-US" sz="1000" dirty="0">
                 <a:solidFill>
                   <a:srgbClr val="FFFFFF"/>
                 </a:solidFill>
@@ -7697,8 +8390,8 @@
         </p:nvSpPr>
         <p:spPr>
           <a:xfrm>
-            <a:off x="1645920" y="1280160"/>
-            <a:ext cx="1097280" cy="1371600"/>
+            <a:off x="1497330" y="1280160"/>
+            <a:ext cx="948690" cy="1371600"/>
           </a:xfrm>
           <a:prstGeom prst="roundRect">
             <a:avLst>
@@ -7712,7 +8405,6 @@
             <a:solidFill>
               <a:srgbClr val="2F6FB5"/>
             </a:solidFill>
-            <a:prstDash val="solid"/>
           </a:ln>
         </p:spPr>
       </p:sp>
@@ -7724,8 +8416,8 @@
         </p:nvSpPr>
         <p:spPr>
           <a:xfrm>
-            <a:off x="1645920" y="1280160"/>
-            <a:ext cx="1097280" cy="1371600"/>
+            <a:off x="1497330" y="1280160"/>
+            <a:ext cx="948690" cy="1371600"/>
           </a:xfrm>
           <a:prstGeom prst="rect">
             <a:avLst/>
@@ -7758,7 +8450,7 @@
               <a:buNone/>
             </a:pPr>
             <a:r>
-              <a:rPr lang="en-US" sz="1200" b="1" dirty="0">
+              <a:rPr lang="en-US" sz="1000" b="1" dirty="0">
                 <a:solidFill>
                   <a:srgbClr val="FFFFFF"/>
                 </a:solidFill>
@@ -7772,7 +8464,7 @@
               <a:buNone/>
             </a:pPr>
             <a:r>
-              <a:rPr lang="en-US" sz="1100" dirty="0">
+              <a:rPr lang="en-US" sz="1000" dirty="0">
                 <a:solidFill>
                   <a:srgbClr val="FFFFFF"/>
                 </a:solidFill>
@@ -7791,8 +8483,8 @@
         </p:nvSpPr>
         <p:spPr>
           <a:xfrm>
-            <a:off x="2834640" y="1280160"/>
-            <a:ext cx="1097280" cy="1371600"/>
+            <a:off x="2537460" y="1280160"/>
+            <a:ext cx="948690" cy="1371600"/>
           </a:xfrm>
           <a:prstGeom prst="roundRect">
             <a:avLst>
@@ -7806,7 +8498,6 @@
             <a:solidFill>
               <a:srgbClr val="0B7A75"/>
             </a:solidFill>
-            <a:prstDash val="solid"/>
           </a:ln>
         </p:spPr>
       </p:sp>
@@ -7818,8 +8509,8 @@
         </p:nvSpPr>
         <p:spPr>
           <a:xfrm>
-            <a:off x="2834640" y="1280160"/>
-            <a:ext cx="1097280" cy="1371600"/>
+            <a:off x="2537460" y="1280160"/>
+            <a:ext cx="948690" cy="1371600"/>
           </a:xfrm>
           <a:prstGeom prst="rect">
             <a:avLst/>
@@ -7852,7 +8543,7 @@
               <a:buNone/>
             </a:pPr>
             <a:r>
-              <a:rPr lang="en-US" sz="1200" b="1" dirty="0">
+              <a:rPr lang="en-US" sz="1000" b="1" dirty="0">
                 <a:solidFill>
                   <a:srgbClr val="FFFFFF"/>
                 </a:solidFill>
@@ -7866,7 +8557,7 @@
               <a:buNone/>
             </a:pPr>
             <a:r>
-              <a:rPr lang="en-US" sz="1100" dirty="0">
+              <a:rPr lang="en-US" sz="1000" dirty="0">
                 <a:solidFill>
                   <a:srgbClr val="FFFFFF"/>
                 </a:solidFill>
@@ -7885,8 +8576,8 @@
         </p:nvSpPr>
         <p:spPr>
           <a:xfrm>
-            <a:off x="4023360" y="1280160"/>
-            <a:ext cx="1097280" cy="1371600"/>
+            <a:off x="3577590" y="1280160"/>
+            <a:ext cx="948690" cy="1371600"/>
           </a:xfrm>
           <a:prstGeom prst="roundRect">
             <a:avLst>
@@ -7900,7 +8591,6 @@
             <a:solidFill>
               <a:srgbClr val="8A4FB0"/>
             </a:solidFill>
-            <a:prstDash val="solid"/>
           </a:ln>
         </p:spPr>
       </p:sp>
@@ -7912,8 +8602,8 @@
         </p:nvSpPr>
         <p:spPr>
           <a:xfrm>
-            <a:off x="4023360" y="1280160"/>
-            <a:ext cx="1097280" cy="1371600"/>
+            <a:off x="3577590" y="1280160"/>
+            <a:ext cx="948690" cy="1371600"/>
           </a:xfrm>
           <a:prstGeom prst="rect">
             <a:avLst/>
@@ -7946,7 +8636,7 @@
               <a:buNone/>
             </a:pPr>
             <a:r>
-              <a:rPr lang="en-US" sz="1200" b="1" dirty="0">
+              <a:rPr lang="en-US" sz="1000" b="1" dirty="0">
                 <a:solidFill>
                   <a:srgbClr val="FFFFFF"/>
                 </a:solidFill>
@@ -7960,7 +8650,7 @@
               <a:buNone/>
             </a:pPr>
             <a:r>
-              <a:rPr lang="en-US" sz="1100" dirty="0">
+              <a:rPr lang="en-US" sz="1000" dirty="0">
                 <a:solidFill>
                   <a:srgbClr val="FFFFFF"/>
                 </a:solidFill>
@@ -7979,8 +8669,8 @@
         </p:nvSpPr>
         <p:spPr>
           <a:xfrm>
-            <a:off x="5212080" y="1280160"/>
-            <a:ext cx="1097280" cy="1371600"/>
+            <a:off x="4617720" y="1280160"/>
+            <a:ext cx="948690" cy="1371600"/>
           </a:xfrm>
           <a:prstGeom prst="roundRect">
             <a:avLst>
@@ -7988,26 +8678,118 @@
             </a:avLst>
           </a:prstGeom>
           <a:solidFill>
-            <a:srgbClr val="FFFFFF"/>
+            <a:srgbClr val="B58AD0"/>
+          </a:solidFill>
+          <a:ln w="19050">
+            <a:solidFill>
+              <a:srgbClr val="B58AD0"/>
+            </a:solidFill>
+          </a:ln>
+        </p:spPr>
+      </p:sp>
+      <p:sp>
+        <p:nvSpPr>
+          <p:cNvPr id="13" name="stage-text-3b"/>
+          <p:cNvSpPr txBox="1"/>
+          <p:nvPr/>
+        </p:nvSpPr>
+        <p:spPr>
+          <a:xfrm>
+            <a:off x="4617720" y="1280160"/>
+            <a:ext cx="948690" cy="1371600"/>
+          </a:xfrm>
+          <a:prstGeom prst="rect">
+            <a:avLst/>
+          </a:prstGeom>
+          <a:noFill/>
+          <a:ln/>
+        </p:spPr>
+        <p:txBody>
+          <a:bodyPr wrap="square" lIns="50800" tIns="50800" rIns="50800" bIns="50800" rtlCol="0" anchor="ctr"/>
+          <a:lstStyle/>
+          <a:p>
+            <a:pPr algn="ctr" indent="0" marL="0">
+              <a:buNone/>
+            </a:pPr>
+            <a:r>
+              <a:rPr lang="en-US" sz="2400" b="1" dirty="0">
+                <a:solidFill>
+                  <a:srgbClr val="FFFFFF"/>
+                </a:solidFill>
+                <a:latin typeface="Cambria" pitchFamily="34" charset="0"/>
+                <a:ea typeface="Cambria" pitchFamily="34" charset="-122"/>
+                <a:cs typeface="Cambria" pitchFamily="34" charset="-120"/>
+              </a:rPr>
+              <a:t>3b</a:t>
+            </a:r>
+            <a:endParaRPr lang="en-US" sz="2400" dirty="0"/>
+          </a:p>
+          <a:p>
+            <a:pPr algn="ctr" indent="0" marL="0">
+              <a:buNone/>
+            </a:pPr>
+            <a:r>
+              <a:rPr lang="en-US" sz="1000" b="1" dirty="0">
+                <a:solidFill>
+                  <a:srgbClr val="FFFFFF"/>
+                </a:solidFill>
+              </a:rPr>
+              <a:t>langchaingo</a:t>
+            </a:r>
+            <a:endParaRPr lang="en-US" sz="2400" dirty="0"/>
+          </a:p>
+          <a:p>
+            <a:pPr algn="ctr" indent="0" marL="0">
+              <a:buNone/>
+            </a:pPr>
+            <a:r>
+              <a:rPr lang="en-US" sz="1000" dirty="0">
+                <a:solidFill>
+                  <a:srgbClr val="FFFFFF"/>
+                </a:solidFill>
+              </a:rPr>
+              <a:t>same, framework</a:t>
+            </a:r>
+            <a:endParaRPr lang="en-US" sz="2400" dirty="0"/>
+          </a:p>
+        </p:txBody>
+      </p:sp>
+      <p:sp>
+        <p:nvSpPr>
+          <p:cNvPr id="14" name="stage-4"/>
+          <p:cNvSpPr/>
+          <p:nvPr/>
+        </p:nvSpPr>
+        <p:spPr>
+          <a:xfrm>
+            <a:off x="5657850" y="1280160"/>
+            <a:ext cx="948690" cy="1371600"/>
+          </a:xfrm>
+          <a:prstGeom prst="roundRect">
+            <a:avLst>
+              <a:gd name="adj" fmla="val 6667"/>
+            </a:avLst>
+          </a:prstGeom>
+          <a:solidFill>
+            <a:srgbClr val="B4561A"/>
           </a:solidFill>
           <a:ln w="19050">
             <a:solidFill>
               <a:srgbClr val="B4561A"/>
             </a:solidFill>
-            <a:prstDash val="dash"/>
           </a:ln>
         </p:spPr>
       </p:sp>
       <p:sp>
         <p:nvSpPr>
-          <p:cNvPr id="13" name="stage-text-3b"/>
+          <p:cNvPr id="15" name="stage-text-4"/>
           <p:cNvSpPr txBox="1"/>
           <p:nvPr/>
         </p:nvSpPr>
         <p:spPr>
           <a:xfrm>
-            <a:off x="5212080" y="1280160"/>
-            <a:ext cx="1097280" cy="1371600"/>
+            <a:off x="5657850" y="1280160"/>
+            <a:ext cx="948690" cy="1371600"/>
           </a:xfrm>
           <a:prstGeom prst="rect">
             <a:avLst/>
@@ -8025,13 +8807,13 @@
             <a:r>
               <a:rPr lang="en-US" sz="2400" b="1" dirty="0">
                 <a:solidFill>
-                  <a:srgbClr val="B4561A"/>
+                  <a:srgbClr val="FFFFFF"/>
                 </a:solidFill>
                 <a:latin typeface="Cambria" pitchFamily="34" charset="0"/>
                 <a:ea typeface="Cambria" pitchFamily="34" charset="-122"/>
                 <a:cs typeface="Cambria" pitchFamily="34" charset="-120"/>
               </a:rPr>
-              <a:t>3b</a:t>
+              <a:t>4</a:t>
             </a:r>
             <a:endParaRPr lang="en-US" sz="2400" dirty="0"/>
           </a:p>
@@ -8040,12 +8822,12 @@
               <a:buNone/>
             </a:pPr>
             <a:r>
-              <a:rPr lang="en-US" sz="1200" b="1" dirty="0">
-                <a:solidFill>
-                  <a:srgbClr val="B4561A"/>
-                </a:solidFill>
-              </a:rPr>
-              <a:t>langchaingo</a:t>
+              <a:rPr lang="en-US" sz="1000" b="1" dirty="0">
+                <a:solidFill>
+                  <a:srgbClr val="FFFFFF"/>
+                </a:solidFill>
+              </a:rPr>
+              <a:t>MCP server</a:t>
             </a:r>
             <a:endParaRPr lang="en-US" sz="2400" dirty="0"/>
           </a:p>
@@ -8054,12 +8836,12 @@
               <a:buNone/>
             </a:pPr>
             <a:r>
-              <a:rPr lang="en-US" sz="1100" dirty="0">
-                <a:solidFill>
-                  <a:srgbClr val="B4561A"/>
-                </a:solidFill>
-              </a:rPr>
-              <a:t>same, framework</a:t>
+              <a:rPr lang="en-US" sz="1000" dirty="0">
+                <a:solidFill>
+                  <a:srgbClr val="FFFFFF"/>
+                </a:solidFill>
+              </a:rPr>
+              <a:t>shared tools</a:t>
             </a:r>
             <a:endParaRPr lang="en-US" sz="2400" dirty="0"/>
           </a:p>
@@ -8067,14 +8849,14 @@
       </p:sp>
       <p:sp>
         <p:nvSpPr>
-          <p:cNvPr id="14" name="stage-4"/>
+          <p:cNvPr id="16" name="stage-5"/>
           <p:cNvSpPr/>
           <p:nvPr/>
         </p:nvSpPr>
         <p:spPr>
           <a:xfrm>
-            <a:off x="6400800" y="1280160"/>
-            <a:ext cx="1097280" cy="1371600"/>
+            <a:off x="6697980" y="1280160"/>
+            <a:ext cx="948690" cy="1371600"/>
           </a:xfrm>
           <a:prstGeom prst="roundRect">
             <a:avLst>
@@ -8082,26 +8864,25 @@
             </a:avLst>
           </a:prstGeom>
           <a:solidFill>
-            <a:srgbClr val="FFFFFF"/>
+            <a:srgbClr val="3F7D2A"/>
           </a:solidFill>
           <a:ln w="19050">
             <a:solidFill>
-              <a:srgbClr val="B4561A"/>
+              <a:srgbClr val="3F7D2A"/>
             </a:solidFill>
-            <a:prstDash val="dash"/>
           </a:ln>
         </p:spPr>
       </p:sp>
       <p:sp>
         <p:nvSpPr>
-          <p:cNvPr id="15" name="stage-text-4"/>
+          <p:cNvPr id="17" name="stage-text-5"/>
           <p:cNvSpPr txBox="1"/>
           <p:nvPr/>
         </p:nvSpPr>
         <p:spPr>
           <a:xfrm>
-            <a:off x="6400800" y="1280160"/>
-            <a:ext cx="1097280" cy="1371600"/>
+            <a:off x="6697980" y="1280160"/>
+            <a:ext cx="948690" cy="1371600"/>
           </a:xfrm>
           <a:prstGeom prst="rect">
             <a:avLst/>
@@ -8119,13 +8900,13 @@
             <a:r>
               <a:rPr lang="en-US" sz="2400" b="1" dirty="0">
                 <a:solidFill>
-                  <a:srgbClr val="B4561A"/>
+                  <a:srgbClr val="FFFFFF"/>
                 </a:solidFill>
                 <a:latin typeface="Cambria" pitchFamily="34" charset="0"/>
                 <a:ea typeface="Cambria" pitchFamily="34" charset="-122"/>
                 <a:cs typeface="Cambria" pitchFamily="34" charset="-120"/>
               </a:rPr>
-              <a:t>4</a:t>
+              <a:t>5</a:t>
             </a:r>
             <a:endParaRPr lang="en-US" sz="2400" dirty="0"/>
           </a:p>
@@ -8134,12 +8915,12 @@
               <a:buNone/>
             </a:pPr>
             <a:r>
-              <a:rPr lang="en-US" sz="1200" b="1" dirty="0">
-                <a:solidFill>
-                  <a:srgbClr val="B4561A"/>
-                </a:solidFill>
-              </a:rPr>
-              <a:t>MCP server</a:t>
+              <a:rPr lang="en-US" sz="1000" b="1" dirty="0">
+                <a:solidFill>
+                  <a:srgbClr val="FFFFFF"/>
+                </a:solidFill>
+              </a:rPr>
+              <a:t>Evals</a:t>
             </a:r>
             <a:endParaRPr lang="en-US" sz="2400" dirty="0"/>
           </a:p>
@@ -8148,12 +8929,12 @@
               <a:buNone/>
             </a:pPr>
             <a:r>
-              <a:rPr lang="en-US" sz="1100" dirty="0">
-                <a:solidFill>
-                  <a:srgbClr val="B4561A"/>
-                </a:solidFill>
-              </a:rPr>
-              <a:t>shared tools</a:t>
+              <a:rPr lang="en-US" sz="1000" dirty="0">
+                <a:solidFill>
+                  <a:srgbClr val="FFFFFF"/>
+                </a:solidFill>
+              </a:rPr>
+              <a:t>measure it</a:t>
             </a:r>
             <a:endParaRPr lang="en-US" sz="2400" dirty="0"/>
           </a:p>
@@ -8161,14 +8942,14 @@
       </p:sp>
       <p:sp>
         <p:nvSpPr>
-          <p:cNvPr id="16" name="stage-5"/>
+          <p:cNvPr id="90" name="stage-6"/>
           <p:cNvSpPr/>
           <p:nvPr/>
         </p:nvSpPr>
         <p:spPr>
           <a:xfrm>
-            <a:off x="7589520" y="1280160"/>
-            <a:ext cx="1097280" cy="1371600"/>
+            <a:off x="7738110" y="1280160"/>
+            <a:ext cx="948690" cy="1371600"/>
           </a:xfrm>
           <a:prstGeom prst="roundRect">
             <a:avLst>
@@ -8176,26 +8957,25 @@
             </a:avLst>
           </a:prstGeom>
           <a:solidFill>
-            <a:srgbClr val="FFFFFF"/>
+            <a:srgbClr val="B02F6B"/>
           </a:solidFill>
           <a:ln w="19050">
             <a:solidFill>
-              <a:srgbClr val="B4561A"/>
+              <a:srgbClr val="B02F6B"/>
             </a:solidFill>
-            <a:prstDash val="dash"/>
           </a:ln>
         </p:spPr>
       </p:sp>
       <p:sp>
         <p:nvSpPr>
-          <p:cNvPr id="17" name="stage-text-5"/>
+          <p:cNvPr id="91" name="stage-text-6"/>
           <p:cNvSpPr txBox="1"/>
           <p:nvPr/>
         </p:nvSpPr>
         <p:spPr>
           <a:xfrm>
-            <a:off x="7589520" y="1280160"/>
-            <a:ext cx="1097280" cy="1371600"/>
+            <a:off x="7738110" y="1280160"/>
+            <a:ext cx="948690" cy="1371600"/>
           </a:xfrm>
           <a:prstGeom prst="rect">
             <a:avLst/>
@@ -8213,13 +8993,13 @@
             <a:r>
               <a:rPr lang="en-US" sz="2400" b="1" dirty="0">
                 <a:solidFill>
-                  <a:srgbClr val="B4561A"/>
+                  <a:srgbClr val="FFFFFF"/>
                 </a:solidFill>
                 <a:latin typeface="Cambria" pitchFamily="34" charset="0"/>
                 <a:ea typeface="Cambria" pitchFamily="34" charset="-122"/>
                 <a:cs typeface="Cambria" pitchFamily="34" charset="-120"/>
               </a:rPr>
-              <a:t>5</a:t>
+              <a:t>6</a:t>
             </a:r>
             <a:endParaRPr lang="en-US" sz="2400" dirty="0"/>
           </a:p>
@@ -8228,12 +9008,12 @@
               <a:buNone/>
             </a:pPr>
             <a:r>
-              <a:rPr lang="en-US" sz="1200" b="1" dirty="0">
-                <a:solidFill>
-                  <a:srgbClr val="B4561A"/>
-                </a:solidFill>
-              </a:rPr>
-              <a:t>Evals</a:t>
+              <a:rPr lang="en-US" sz="1000" b="1" dirty="0">
+                <a:solidFill>
+                  <a:srgbClr val="FFFFFF"/>
+                </a:solidFill>
+              </a:rPr>
+              <a:t>Providers</a:t>
             </a:r>
             <a:endParaRPr lang="en-US" sz="2400" dirty="0"/>
           </a:p>
@@ -8242,12 +9022,12 @@
               <a:buNone/>
             </a:pPr>
             <a:r>
-              <a:rPr lang="en-US" sz="1100" dirty="0">
-                <a:solidFill>
-                  <a:srgbClr val="B4561A"/>
-                </a:solidFill>
-              </a:rPr>
-              <a:t>measure it</a:t>
+              <a:rPr lang="en-US" sz="1000" dirty="0">
+                <a:solidFill>
+                  <a:srgbClr val="FFFFFF"/>
+                </a:solidFill>
+              </a:rPr>
+              <a:t>any model</a:t>
             </a:r>
             <a:endParaRPr lang="en-US" sz="2400" dirty="0"/>
           </a:p>
@@ -8283,7 +9063,7 @@
                   <a:schemeClr val="tx1"/>
                 </a:solidFill>
               </a:rPr>
-              <a:t>Each stage hands a little more control from your code to the model.</a:t>
+              <a:t>Each stage hands a little more control from your code to the model, then measures the result.</a:t>
             </a:r>
             <a:endParaRPr lang="en-US" sz="1800" dirty="0"/>
           </a:p>

</xml_diff>